<commit_message>
fix(pitch): afinar textos del problema y del material
Portada sin duplicar el placeholder del hackathon, el problema menciona Pinterest y la lista de materiales incluye el numero de placas. Regenerado el .pptx.
</commit_message>
<xml_diff>
--- a/pitch/pixel-pattern-pitch.pptx
+++ b/pitch/pixel-pattern-pitch.pptx
@@ -4264,7 +4264,7 @@
                 </a:solidFill>
                 <a:latin typeface="Segoe UI"/>
               </a:rPr>
-              <a:t>HACKATHON · [NOMBRE DEL HACKATHON]</a:t>
+              <a:t>PITCH · 4 MINUTOS</a:t>
             </a:r>
           </a:p>
         </p:txBody>
@@ -9180,7 +9180,7 @@
                 </a:solidFill>
                 <a:latin typeface="Segoe UI"/>
               </a:rPr>
-              <a:t>Patrones dispersos, sin progreso</a:t>
+              <a:t>Dispersos en Pinterest, sin forma de hacerlos</a:t>
             </a:r>
           </a:p>
         </p:txBody>
@@ -14567,7 +14567,7 @@
                 </a:solidFill>
                 <a:latin typeface="Segoe UI"/>
               </a:rPr>
-              <a:t>Lista de materiales y placas</a:t>
+              <a:t>Lista de materiales y nº de placas</a:t>
             </a:r>
           </a:p>
         </p:txBody>

</xml_diff>